<commit_message>
Week 10 - input forms
</commit_message>
<xml_diff>
--- a/Classes/Week 08 - Data 1/Class 08 - Data 01.pptx
+++ b/Classes/Week 08 - Data 1/Class 08 - Data 01.pptx
@@ -4282,7 +4282,7 @@
           <p:nvPr>
             <p:extLst>
               <p:ext uri="{D42A27DB-BD31-4B8C-83A1-F6EECF244321}">
-                <p14:modId xmlns:p14="http://schemas.microsoft.com/office/powerpoint/2010/main" val="3866781601"/>
+                <p14:modId xmlns:p14="http://schemas.microsoft.com/office/powerpoint/2010/main" val="3821929281"/>
               </p:ext>
             </p:extLst>
           </p:nvPr>
@@ -4425,10 +4425,7 @@
                     <a:lstStyle/>
                     <a:p>
                       <a:pPr algn="r"/>
-                      <a:r>
-                        <a:rPr lang="en-US" dirty="0"/>
-                        <a:t>Mustang</a:t>
-                      </a:r>
+                      <a:endParaRPr lang="en-US" dirty="0"/>
                     </a:p>
                   </a:txBody>
                   <a:tcPr/>
@@ -4600,7 +4597,7 @@
         <p:spPr>
           <a:xfrm>
             <a:off x="388620" y="4028440"/>
-            <a:ext cx="6995160" cy="3046988"/>
+            <a:ext cx="6995160" cy="2769989"/>
           </a:xfrm>
           <a:prstGeom prst="rect">
             <a:avLst/>
@@ -4718,38 +4715,7 @@
             </a:r>
             <a:r>
               <a:rPr lang="en-US" dirty="0"/>
-              <a:t> &lt;</a:t>
-            </a:r>
-            <a:r>
-              <a:rPr lang="en-US" dirty="0" err="1"/>
-              <a:t>cr</a:t>
-            </a:r>
-            <a:r>
-              <a:rPr lang="en-US" dirty="0"/>
-              <a:t>&gt;</a:t>
-            </a:r>
-          </a:p>
-          <a:p>
-            <a:pPr>
-              <a:tabLst>
-                <a:tab pos="228600" algn="l"/>
-                <a:tab pos="457200" algn="l"/>
-                <a:tab pos="685800" algn="l"/>
-                <a:tab pos="914400" algn="l"/>
-                <a:tab pos="1143000" algn="l"/>
-              </a:tabLst>
-            </a:pPr>
-            <a:r>
-              <a:rPr lang="en-US" dirty="0"/>
-              <a:t>00001,Ford,Mustang,1964 &lt;</a:t>
-            </a:r>
-            <a:r>
-              <a:rPr lang="en-US" dirty="0" err="1"/>
-              <a:t>cr</a:t>
-            </a:r>
-            <a:r>
-              <a:rPr lang="en-US" dirty="0"/>
-              <a:t>&gt;</a:t>
+              <a:t>\n00001,Ford,,1964\n</a:t>
             </a:r>
           </a:p>
           <a:p>

</xml_diff>